<commit_message>
simplify funding group names into acronyms
</commit_message>
<xml_diff>
--- a/figures/btg-effect/barplot-allpanels.pptx
+++ b/figures/btg-effect/barplot-allpanels.pptx
@@ -6,6 +6,7 @@
   </p:sldMasterIdLst>
   <p:sldIdLst>
     <p:sldId id="256" r:id="rId2"/>
+    <p:sldId id="257" r:id="rId3"/>
   </p:sldIdLst>
   <p:sldSz cx="3240088" cy="3600450"/>
   <p:notesSz cx="6858000" cy="9144000"/>
@@ -104,6 +105,11 @@
       </a:defRPr>
     </a:lvl9pPr>
   </p:defaultTextStyle>
+  <p:extLst>
+    <p:ext uri="{EFAFB233-063F-42B5-8137-9DF3F51BA10A}">
+      <p15:sldGuideLst xmlns:p15="http://schemas.microsoft.com/office/powerpoint/2012/main"/>
+    </p:ext>
+  </p:extLst>
 </p:presentation>
 </file>
 
@@ -238,7 +244,7 @@
           <a:p>
             <a:fld id="{4F074355-C6C9-314C-AC75-37C4D08C6C34}" type="datetimeFigureOut">
               <a:rPr lang="en-CA" smtClean="0"/>
-              <a:t>2026-05-29</a:t>
+              <a:t>2026-06-23</a:t>
             </a:fld>
             <a:endParaRPr lang="en-CA"/>
           </a:p>
@@ -408,7 +414,7 @@
           <a:p>
             <a:fld id="{4F074355-C6C9-314C-AC75-37C4D08C6C34}" type="datetimeFigureOut">
               <a:rPr lang="en-CA" smtClean="0"/>
-              <a:t>2026-05-29</a:t>
+              <a:t>2026-06-23</a:t>
             </a:fld>
             <a:endParaRPr lang="en-CA"/>
           </a:p>
@@ -588,7 +594,7 @@
           <a:p>
             <a:fld id="{4F074355-C6C9-314C-AC75-37C4D08C6C34}" type="datetimeFigureOut">
               <a:rPr lang="en-CA" smtClean="0"/>
-              <a:t>2026-05-29</a:t>
+              <a:t>2026-06-23</a:t>
             </a:fld>
             <a:endParaRPr lang="en-CA"/>
           </a:p>
@@ -758,7 +764,7 @@
           <a:p>
             <a:fld id="{4F074355-C6C9-314C-AC75-37C4D08C6C34}" type="datetimeFigureOut">
               <a:rPr lang="en-CA" smtClean="0"/>
-              <a:t>2026-05-29</a:t>
+              <a:t>2026-06-23</a:t>
             </a:fld>
             <a:endParaRPr lang="en-CA"/>
           </a:p>
@@ -1004,7 +1010,7 @@
           <a:p>
             <a:fld id="{4F074355-C6C9-314C-AC75-37C4D08C6C34}" type="datetimeFigureOut">
               <a:rPr lang="en-CA" smtClean="0"/>
-              <a:t>2026-05-29</a:t>
+              <a:t>2026-06-23</a:t>
             </a:fld>
             <a:endParaRPr lang="en-CA"/>
           </a:p>
@@ -1236,7 +1242,7 @@
           <a:p>
             <a:fld id="{4F074355-C6C9-314C-AC75-37C4D08C6C34}" type="datetimeFigureOut">
               <a:rPr lang="en-CA" smtClean="0"/>
-              <a:t>2026-05-29</a:t>
+              <a:t>2026-06-23</a:t>
             </a:fld>
             <a:endParaRPr lang="en-CA"/>
           </a:p>
@@ -1603,7 +1609,7 @@
           <a:p>
             <a:fld id="{4F074355-C6C9-314C-AC75-37C4D08C6C34}" type="datetimeFigureOut">
               <a:rPr lang="en-CA" smtClean="0"/>
-              <a:t>2026-05-29</a:t>
+              <a:t>2026-06-23</a:t>
             </a:fld>
             <a:endParaRPr lang="en-CA"/>
           </a:p>
@@ -1721,7 +1727,7 @@
           <a:p>
             <a:fld id="{4F074355-C6C9-314C-AC75-37C4D08C6C34}" type="datetimeFigureOut">
               <a:rPr lang="en-CA" smtClean="0"/>
-              <a:t>2026-05-29</a:t>
+              <a:t>2026-06-23</a:t>
             </a:fld>
             <a:endParaRPr lang="en-CA"/>
           </a:p>
@@ -1816,7 +1822,7 @@
           <a:p>
             <a:fld id="{4F074355-C6C9-314C-AC75-37C4D08C6C34}" type="datetimeFigureOut">
               <a:rPr lang="en-CA" smtClean="0"/>
-              <a:t>2026-05-29</a:t>
+              <a:t>2026-06-23</a:t>
             </a:fld>
             <a:endParaRPr lang="en-CA"/>
           </a:p>
@@ -2093,7 +2099,7 @@
           <a:p>
             <a:fld id="{4F074355-C6C9-314C-AC75-37C4D08C6C34}" type="datetimeFigureOut">
               <a:rPr lang="en-CA" smtClean="0"/>
-              <a:t>2026-05-29</a:t>
+              <a:t>2026-06-23</a:t>
             </a:fld>
             <a:endParaRPr lang="en-CA"/>
           </a:p>
@@ -2350,7 +2356,7 @@
           <a:p>
             <a:fld id="{4F074355-C6C9-314C-AC75-37C4D08C6C34}" type="datetimeFigureOut">
               <a:rPr lang="en-CA" smtClean="0"/>
-              <a:t>2026-05-29</a:t>
+              <a:t>2026-06-23</a:t>
             </a:fld>
             <a:endParaRPr lang="en-CA"/>
           </a:p>
@@ -2563,7 +2569,7 @@
           <a:p>
             <a:fld id="{4F074355-C6C9-314C-AC75-37C4D08C6C34}" type="datetimeFigureOut">
               <a:rPr lang="en-CA" smtClean="0"/>
-              <a:t>2026-05-29</a:t>
+              <a:t>2026-06-23</a:t>
             </a:fld>
             <a:endParaRPr lang="en-CA"/>
           </a:p>
@@ -2968,52 +2974,439 @@
           <a:chExt cx="0" cy="0"/>
         </a:xfrm>
       </p:grpSpPr>
-      <p:grpSp>
-        <p:nvGrpSpPr>
-          <p:cNvPr id="24" name="Group 23">
+      <p:pic>
+        <p:nvPicPr>
+          <p:cNvPr id="5" name="Picture 4" descr="A graph of different colored bars&#10;&#10;Description automatically generated with medium confidence">
             <a:extLst>
               <a:ext uri="{FF2B5EF4-FFF2-40B4-BE49-F238E27FC236}">
-                <a16:creationId xmlns:a16="http://schemas.microsoft.com/office/drawing/2014/main" id="{0D4B7254-396F-29CD-F996-4D7B4A6F0AE2}"/>
+                <a16:creationId xmlns:a16="http://schemas.microsoft.com/office/drawing/2014/main" id="{977DCEB8-06F9-06A8-F0A3-FD05C8CD454D}"/>
               </a:ext>
             </a:extLst>
           </p:cNvPr>
-          <p:cNvGrpSpPr/>
+          <p:cNvPicPr>
+            <a:picLocks noChangeAspect="1"/>
+          </p:cNvPicPr>
+          <p:nvPr/>
+        </p:nvPicPr>
+        <p:blipFill>
+          <a:blip r:embed="rId2">
+            <a:alphaModFix/>
+          </a:blip>
+          <a:stretch>
+            <a:fillRect/>
+          </a:stretch>
+        </p:blipFill>
+        <p:spPr>
+          <a:xfrm>
+            <a:off x="153048" y="166422"/>
+            <a:ext cx="2936127" cy="2941207"/>
+          </a:xfrm>
+          <a:prstGeom prst="rect">
+            <a:avLst/>
+          </a:prstGeom>
+        </p:spPr>
+      </p:pic>
+      <p:sp>
+        <p:nvSpPr>
+          <p:cNvPr id="18" name="Rectangle 17">
+            <a:extLst>
+              <a:ext uri="{FF2B5EF4-FFF2-40B4-BE49-F238E27FC236}">
+                <a16:creationId xmlns:a16="http://schemas.microsoft.com/office/drawing/2014/main" id="{DCF79076-1245-6147-C0C4-53029BF2E719}"/>
+              </a:ext>
+            </a:extLst>
+          </p:cNvPr>
+          <p:cNvSpPr/>
+          <p:nvPr/>
+        </p:nvSpPr>
+        <p:spPr>
+          <a:xfrm>
+            <a:off x="82820" y="104924"/>
+            <a:ext cx="3396501" cy="3064205"/>
+          </a:xfrm>
+          <a:prstGeom prst="rect">
+            <a:avLst/>
+          </a:prstGeom>
+          <a:solidFill>
+            <a:schemeClr val="bg1"/>
+          </a:solidFill>
+          <a:ln>
+            <a:noFill/>
+          </a:ln>
+        </p:spPr>
+        <p:style>
+          <a:lnRef idx="2">
+            <a:schemeClr val="accent1">
+              <a:shade val="15000"/>
+            </a:schemeClr>
+          </a:lnRef>
+          <a:fillRef idx="1">
+            <a:schemeClr val="accent1"/>
+          </a:fillRef>
+          <a:effectRef idx="0">
+            <a:schemeClr val="accent1"/>
+          </a:effectRef>
+          <a:fontRef idx="minor">
+            <a:schemeClr val="lt1"/>
+          </a:fontRef>
+        </p:style>
+        <p:txBody>
+          <a:bodyPr rtlCol="0" anchor="ctr"/>
+          <a:lstStyle/>
+          <a:p>
+            <a:pPr algn="ctr"/>
+            <a:endParaRPr lang="en-CA"/>
+          </a:p>
+        </p:txBody>
+      </p:sp>
+      <p:sp>
+        <p:nvSpPr>
+          <p:cNvPr id="20" name="TextBox 19">
+            <a:extLst>
+              <a:ext uri="{FF2B5EF4-FFF2-40B4-BE49-F238E27FC236}">
+                <a16:creationId xmlns:a16="http://schemas.microsoft.com/office/drawing/2014/main" id="{C49764AE-06B5-5B82-58B1-4E417C8CDFCE}"/>
+              </a:ext>
+            </a:extLst>
+          </p:cNvPr>
+          <p:cNvSpPr txBox="1"/>
+          <p:nvPr/>
+        </p:nvSpPr>
+        <p:spPr>
+          <a:xfrm>
+            <a:off x="2546986" y="450118"/>
+            <a:ext cx="693102" cy="107722"/>
+          </a:xfrm>
+          <a:prstGeom prst="rect">
+            <a:avLst/>
+          </a:prstGeom>
+          <a:solidFill>
+            <a:schemeClr val="bg1"/>
+          </a:solidFill>
+        </p:spPr>
+        <p:txBody>
+          <a:bodyPr wrap="square" lIns="0" tIns="0" bIns="0" rtlCol="0">
+            <a:spAutoFit/>
+          </a:bodyPr>
+          <a:lstStyle/>
+          <a:p>
+            <a:r>
+              <a:rPr lang="en-CA" sz="700" dirty="0">
+                <a:latin typeface="Roboto Condensed" pitchFamily="2" charset="0"/>
+                <a:ea typeface="Roboto Condensed" pitchFamily="2" charset="0"/>
+              </a:rPr>
+              <a:t>BTG Effect</a:t>
+            </a:r>
+          </a:p>
+        </p:txBody>
+      </p:sp>
+      <p:sp>
+        <p:nvSpPr>
+          <p:cNvPr id="21" name="TextBox 20">
+            <a:extLst>
+              <a:ext uri="{FF2B5EF4-FFF2-40B4-BE49-F238E27FC236}">
+                <a16:creationId xmlns:a16="http://schemas.microsoft.com/office/drawing/2014/main" id="{2D6FCE85-8B3E-AA5E-16D5-8F1791D26FEA}"/>
+              </a:ext>
+            </a:extLst>
+          </p:cNvPr>
+          <p:cNvSpPr txBox="1"/>
+          <p:nvPr/>
+        </p:nvSpPr>
+        <p:spPr>
+          <a:xfrm>
+            <a:off x="2550964" y="577794"/>
+            <a:ext cx="693102" cy="107722"/>
+          </a:xfrm>
+          <a:prstGeom prst="rect">
+            <a:avLst/>
+          </a:prstGeom>
+          <a:solidFill>
+            <a:schemeClr val="bg1"/>
+          </a:solidFill>
+        </p:spPr>
+        <p:txBody>
+          <a:bodyPr wrap="square" lIns="0" tIns="0" bIns="0" rtlCol="0">
+            <a:spAutoFit/>
+          </a:bodyPr>
+          <a:lstStyle/>
+          <a:p>
+            <a:r>
+              <a:rPr lang="en-CA" sz="700" dirty="0">
+                <a:latin typeface="Roboto Condensed" pitchFamily="2" charset="0"/>
+                <a:ea typeface="Roboto Condensed" pitchFamily="2" charset="0"/>
+              </a:rPr>
+              <a:t>Bioblitz Effect</a:t>
+            </a:r>
+          </a:p>
+        </p:txBody>
+      </p:sp>
+      <p:sp>
+        <p:nvSpPr>
+          <p:cNvPr id="22" name="TextBox 21">
+            <a:extLst>
+              <a:ext uri="{FF2B5EF4-FFF2-40B4-BE49-F238E27FC236}">
+                <a16:creationId xmlns:a16="http://schemas.microsoft.com/office/drawing/2014/main" id="{DD39B340-D881-D7D1-7FDB-D15069D4E1F9}"/>
+              </a:ext>
+            </a:extLst>
+          </p:cNvPr>
+          <p:cNvSpPr txBox="1"/>
+          <p:nvPr/>
+        </p:nvSpPr>
+        <p:spPr>
+          <a:xfrm>
+            <a:off x="2546189" y="707322"/>
+            <a:ext cx="693102" cy="107722"/>
+          </a:xfrm>
+          <a:prstGeom prst="rect">
+            <a:avLst/>
+          </a:prstGeom>
+          <a:solidFill>
+            <a:schemeClr val="bg1"/>
+          </a:solidFill>
+        </p:spPr>
+        <p:txBody>
+          <a:bodyPr wrap="square" lIns="0" tIns="0" bIns="0" rtlCol="0">
+            <a:spAutoFit/>
+          </a:bodyPr>
+          <a:lstStyle/>
+          <a:p>
+            <a:r>
+              <a:rPr lang="en-CA" sz="700" dirty="0">
+                <a:latin typeface="Roboto Condensed" pitchFamily="2" charset="0"/>
+                <a:ea typeface="Roboto Condensed" pitchFamily="2" charset="0"/>
+              </a:rPr>
+              <a:t>Funding Effect</a:t>
+            </a:r>
+          </a:p>
+        </p:txBody>
+      </p:sp>
+      <p:sp>
+        <p:nvSpPr>
+          <p:cNvPr id="23" name="TextBox 22">
+            <a:extLst>
+              <a:ext uri="{FF2B5EF4-FFF2-40B4-BE49-F238E27FC236}">
+                <a16:creationId xmlns:a16="http://schemas.microsoft.com/office/drawing/2014/main" id="{14AAD9EC-2009-535C-0834-489D500A09FB}"/>
+              </a:ext>
+            </a:extLst>
+          </p:cNvPr>
+          <p:cNvSpPr txBox="1"/>
+          <p:nvPr/>
+        </p:nvSpPr>
+        <p:spPr>
+          <a:xfrm>
+            <a:off x="2546189" y="826064"/>
+            <a:ext cx="693102" cy="107722"/>
+          </a:xfrm>
+          <a:prstGeom prst="rect">
+            <a:avLst/>
+          </a:prstGeom>
+          <a:solidFill>
+            <a:schemeClr val="bg1"/>
+          </a:solidFill>
+        </p:spPr>
+        <p:txBody>
+          <a:bodyPr wrap="square" lIns="0" tIns="0" bIns="0" rtlCol="0">
+            <a:spAutoFit/>
+          </a:bodyPr>
+          <a:lstStyle/>
+          <a:p>
+            <a:r>
+              <a:rPr lang="en-CA" sz="700" dirty="0">
+                <a:latin typeface="Roboto Condensed" pitchFamily="2" charset="0"/>
+                <a:ea typeface="Roboto Condensed" pitchFamily="2" charset="0"/>
+              </a:rPr>
+              <a:t>Expectation</a:t>
+            </a:r>
+          </a:p>
+        </p:txBody>
+      </p:sp>
+      <p:grpSp>
+        <p:nvGrpSpPr>
+          <p:cNvPr id="15" name="Group 14">
+            <a:extLst>
+              <a:ext uri="{FF2B5EF4-FFF2-40B4-BE49-F238E27FC236}">
+                <a16:creationId xmlns:a16="http://schemas.microsoft.com/office/drawing/2014/main" id="{8A3C0CDA-857B-1C7D-30D6-2ADDA00FBF0F}"/>
+              </a:ext>
+            </a:extLst>
+          </p:cNvPr>
+          <p:cNvGrpSpPr>
+            <a:grpSpLocks noChangeAspect="1"/>
+          </p:cNvGrpSpPr>
           <p:nvPr/>
         </p:nvGrpSpPr>
         <p:grpSpPr>
           <a:xfrm>
-            <a:off x="82820" y="104924"/>
-            <a:ext cx="3454087" cy="3064205"/>
-            <a:chOff x="82820" y="104924"/>
-            <a:chExt cx="3454087" cy="3064205"/>
+            <a:off x="2371611" y="442823"/>
+            <a:ext cx="739650" cy="501983"/>
+            <a:chOff x="3240088" y="255583"/>
+            <a:chExt cx="1711594" cy="1161618"/>
           </a:xfrm>
         </p:grpSpPr>
-        <p:grpSp>
-          <p:nvGrpSpPr>
-            <p:cNvPr id="19" name="Group 18">
+        <p:sp>
+          <p:nvSpPr>
+            <p:cNvPr id="8" name="Rectangle 7">
               <a:extLst>
                 <a:ext uri="{FF2B5EF4-FFF2-40B4-BE49-F238E27FC236}">
-                  <a16:creationId xmlns:a16="http://schemas.microsoft.com/office/drawing/2014/main" id="{57BBDF10-C2FB-D5F7-AD76-775964F0A75E}"/>
+                  <a16:creationId xmlns:a16="http://schemas.microsoft.com/office/drawing/2014/main" id="{291B02BE-F5DF-5B97-DCF6-66B720E3C4D7}"/>
                 </a:ext>
               </a:extLst>
             </p:cNvPr>
-            <p:cNvGrpSpPr/>
+            <p:cNvSpPr/>
+            <p:nvPr/>
+          </p:nvSpPr>
+          <p:spPr>
+            <a:xfrm>
+              <a:off x="3240088" y="255583"/>
+              <a:ext cx="1711594" cy="1161618"/>
+            </a:xfrm>
+            <a:prstGeom prst="rect">
+              <a:avLst/>
+            </a:prstGeom>
+            <a:solidFill>
+              <a:schemeClr val="bg1"/>
+            </a:solidFill>
+            <a:ln>
+              <a:noFill/>
+            </a:ln>
+          </p:spPr>
+          <p:style>
+            <a:lnRef idx="2">
+              <a:schemeClr val="accent1">
+                <a:shade val="15000"/>
+              </a:schemeClr>
+            </a:lnRef>
+            <a:fillRef idx="1">
+              <a:schemeClr val="accent1"/>
+            </a:fillRef>
+            <a:effectRef idx="0">
+              <a:schemeClr val="accent1"/>
+            </a:effectRef>
+            <a:fontRef idx="minor">
+              <a:schemeClr val="lt1"/>
+            </a:fontRef>
+          </p:style>
+          <p:txBody>
+            <a:bodyPr rtlCol="0" anchor="ctr"/>
+            <a:lstStyle/>
+            <a:p>
+              <a:pPr algn="ctr"/>
+              <a:endParaRPr lang="en-CA"/>
+            </a:p>
+          </p:txBody>
+        </p:sp>
+        <p:grpSp>
+          <p:nvGrpSpPr>
+            <p:cNvPr id="9" name="Group 8">
+              <a:extLst>
+                <a:ext uri="{FF2B5EF4-FFF2-40B4-BE49-F238E27FC236}">
+                  <a16:creationId xmlns:a16="http://schemas.microsoft.com/office/drawing/2014/main" id="{9FAC2967-BC6B-20FD-74FD-4D81DDC2C117}"/>
+                </a:ext>
+              </a:extLst>
+            </p:cNvPr>
+            <p:cNvGrpSpPr>
+              <a:grpSpLocks noChangeAspect="1"/>
+            </p:cNvGrpSpPr>
             <p:nvPr/>
           </p:nvGrpSpPr>
           <p:grpSpPr>
             <a:xfrm>
-              <a:off x="82820" y="104924"/>
-              <a:ext cx="3454087" cy="3064205"/>
-              <a:chOff x="82820" y="99173"/>
-              <a:chExt cx="3454087" cy="3064205"/>
+              <a:off x="3260676" y="255583"/>
+              <a:ext cx="1691006" cy="1161618"/>
+              <a:chOff x="9482516" y="765949"/>
+              <a:chExt cx="1147704" cy="788402"/>
             </a:xfrm>
           </p:grpSpPr>
+          <p:pic>
+            <p:nvPicPr>
+              <p:cNvPr id="10" name="Picture 9" descr="A graph of different colored bars&#10;&#10;Description automatically generated">
+                <a:extLst>
+                  <a:ext uri="{FF2B5EF4-FFF2-40B4-BE49-F238E27FC236}">
+                    <a16:creationId xmlns:a16="http://schemas.microsoft.com/office/drawing/2014/main" id="{1B48769C-57FC-8D2D-908D-B2F669A7BDBB}"/>
+                  </a:ext>
+                </a:extLst>
+              </p:cNvPr>
+              <p:cNvPicPr>
+                <a:picLocks noChangeAspect="1"/>
+              </p:cNvPicPr>
+              <p:nvPr/>
+            </p:nvPicPr>
+            <p:blipFill>
+              <a:blip r:embed="rId3"/>
+              <a:srcRect l="13303" t="8758" r="76614" b="88440"/>
+              <a:stretch/>
+            </p:blipFill>
+            <p:spPr>
+              <a:xfrm>
+                <a:off x="9485166" y="765949"/>
+                <a:ext cx="933612" cy="192100"/>
+              </a:xfrm>
+              <a:prstGeom prst="rect">
+                <a:avLst/>
+              </a:prstGeom>
+            </p:spPr>
+          </p:pic>
+          <p:pic>
+            <p:nvPicPr>
+              <p:cNvPr id="11" name="Picture 10" descr="A graph of different colored bars&#10;&#10;Description automatically generated">
+                <a:extLst>
+                  <a:ext uri="{FF2B5EF4-FFF2-40B4-BE49-F238E27FC236}">
+                    <a16:creationId xmlns:a16="http://schemas.microsoft.com/office/drawing/2014/main" id="{22710543-E87F-7C86-EEB1-E10A6764365B}"/>
+                  </a:ext>
+                </a:extLst>
+              </p:cNvPr>
+              <p:cNvPicPr>
+                <a:picLocks noChangeAspect="1"/>
+              </p:cNvPicPr>
+              <p:nvPr/>
+            </p:nvPicPr>
+            <p:blipFill>
+              <a:blip r:embed="rId3"/>
+              <a:srcRect l="40980" t="9132" r="47263" b="88496"/>
+              <a:stretch/>
+            </p:blipFill>
+            <p:spPr>
+              <a:xfrm>
+                <a:off x="9506962" y="986221"/>
+                <a:ext cx="1088570" cy="162646"/>
+              </a:xfrm>
+              <a:prstGeom prst="rect">
+                <a:avLst/>
+              </a:prstGeom>
+            </p:spPr>
+          </p:pic>
+          <p:pic>
+            <p:nvPicPr>
+              <p:cNvPr id="12" name="Picture 11" descr="A graph of different colored bars&#10;&#10;Description automatically generated">
+                <a:extLst>
+                  <a:ext uri="{FF2B5EF4-FFF2-40B4-BE49-F238E27FC236}">
+                    <a16:creationId xmlns:a16="http://schemas.microsoft.com/office/drawing/2014/main" id="{C7E290C8-BF37-938F-7800-1BE466EC699A}"/>
+                  </a:ext>
+                </a:extLst>
+              </p:cNvPr>
+              <p:cNvPicPr>
+                <a:picLocks noChangeAspect="1"/>
+              </p:cNvPicPr>
+              <p:nvPr/>
+            </p:nvPicPr>
+            <p:blipFill>
+              <a:blip r:embed="rId3"/>
+              <a:srcRect l="69279" t="9118" r="18549" b="88229"/>
+              <a:stretch/>
+            </p:blipFill>
+            <p:spPr>
+              <a:xfrm>
+                <a:off x="9503230" y="1177040"/>
+                <a:ext cx="1126990" cy="181889"/>
+              </a:xfrm>
+              <a:prstGeom prst="rect">
+                <a:avLst/>
+              </a:prstGeom>
+            </p:spPr>
+          </p:pic>
           <p:sp>
             <p:nvSpPr>
-              <p:cNvPr id="18" name="Rectangle 17">
+              <p:cNvPr id="13" name="Rectangle 12">
                 <a:extLst>
                   <a:ext uri="{FF2B5EF4-FFF2-40B4-BE49-F238E27FC236}">
-                    <a16:creationId xmlns:a16="http://schemas.microsoft.com/office/drawing/2014/main" id="{DCF79076-1245-6147-C0C4-53029BF2E719}"/>
+                    <a16:creationId xmlns:a16="http://schemas.microsoft.com/office/drawing/2014/main" id="{A266BE03-F4E6-395F-9EBE-AD5000DD37D9}"/>
                   </a:ext>
                 </a:extLst>
               </p:cNvPr>
@@ -3022,8 +3415,8 @@
             </p:nvSpPr>
             <p:spPr>
               <a:xfrm>
-                <a:off x="82820" y="99173"/>
-                <a:ext cx="3396501" cy="3064205"/>
+                <a:off x="9482516" y="1336186"/>
+                <a:ext cx="202660" cy="104503"/>
               </a:xfrm>
               <a:prstGeom prst="rect">
                 <a:avLst/>
@@ -3062,10 +3455,10 @@
           </p:sp>
           <p:pic>
             <p:nvPicPr>
-              <p:cNvPr id="7" name="Picture 6" descr="A graph of different colored and black bars&#10;&#10;Description automatically generated with medium confidence">
+              <p:cNvPr id="14" name="Picture 13" descr="A graph of different colored bars&#10;&#10;Description automatically generated">
                 <a:extLst>
                   <a:ext uri="{FF2B5EF4-FFF2-40B4-BE49-F238E27FC236}">
-                    <a16:creationId xmlns:a16="http://schemas.microsoft.com/office/drawing/2014/main" id="{A993C800-698B-5F36-B09E-BE36FB5F4BCA}"/>
+                    <a16:creationId xmlns:a16="http://schemas.microsoft.com/office/drawing/2014/main" id="{5A64326F-D0E3-7F75-97B1-2C7FCAE6CA1A}"/>
                   </a:ext>
                 </a:extLst>
               </p:cNvPr>
@@ -3075,26 +3468,280 @@
               <p:nvPr/>
             </p:nvPicPr>
             <p:blipFill>
-              <a:blip r:embed="rId2"/>
-              <a:srcRect l="2556" b="5591"/>
+              <a:blip r:embed="rId3"/>
+              <a:srcRect l="69279" t="11611" r="18549" b="85736"/>
               <a:stretch/>
             </p:blipFill>
             <p:spPr>
               <a:xfrm>
-                <a:off x="82820" y="99173"/>
-                <a:ext cx="3157268" cy="3064205"/>
+                <a:off x="9503230" y="1372463"/>
+                <a:ext cx="1126990" cy="181888"/>
               </a:xfrm>
               <a:prstGeom prst="rect">
                 <a:avLst/>
               </a:prstGeom>
             </p:spPr>
           </p:pic>
+        </p:grpSp>
+      </p:grpSp>
+      <p:sp>
+        <p:nvSpPr>
+          <p:cNvPr id="17" name="TextBox 16">
+            <a:extLst>
+              <a:ext uri="{FF2B5EF4-FFF2-40B4-BE49-F238E27FC236}">
+                <a16:creationId xmlns:a16="http://schemas.microsoft.com/office/drawing/2014/main" id="{E5CE0926-D296-AD78-EF60-7803D78B1D42}"/>
+              </a:ext>
+            </a:extLst>
+          </p:cNvPr>
+          <p:cNvSpPr txBox="1"/>
+          <p:nvPr/>
+        </p:nvSpPr>
+        <p:spPr>
+          <a:xfrm>
+            <a:off x="3019322" y="2156605"/>
+            <a:ext cx="517585" cy="200055"/>
+          </a:xfrm>
+          <a:prstGeom prst="rect">
+            <a:avLst/>
+          </a:prstGeom>
+          <a:noFill/>
+        </p:spPr>
+        <p:txBody>
+          <a:bodyPr wrap="square" rtlCol="0">
+            <a:spAutoFit/>
+          </a:bodyPr>
+          <a:lstStyle/>
+          <a:p>
+            <a:r>
+              <a:rPr lang="en-CA" sz="700" dirty="0">
+                <a:latin typeface="Roboto Condensed Light" pitchFamily="2" charset="0"/>
+                <a:ea typeface="Roboto Condensed Light" pitchFamily="2" charset="0"/>
+              </a:rPr>
+              <a:t>doubling</a:t>
+            </a:r>
+          </a:p>
+        </p:txBody>
+      </p:sp>
+    </p:spTree>
+    <p:extLst>
+      <p:ext uri="{BB962C8B-B14F-4D97-AF65-F5344CB8AC3E}">
+        <p14:creationId xmlns:p14="http://schemas.microsoft.com/office/powerpoint/2010/main" val="3188471139"/>
+      </p:ext>
+    </p:extLst>
+  </p:cSld>
+  <p:clrMapOvr>
+    <a:masterClrMapping/>
+  </p:clrMapOvr>
+</p:sld>
+</file>
+
+<file path=ppt/slides/slide2.xml><?xml version="1.0" encoding="utf-8"?>
+<p:sld xmlns:a="http://schemas.openxmlformats.org/drawingml/2006/main" xmlns:r="http://schemas.openxmlformats.org/officeDocument/2006/relationships" xmlns:p="http://schemas.openxmlformats.org/presentationml/2006/main">
+  <p:cSld>
+    <p:spTree>
+      <p:nvGrpSpPr>
+        <p:cNvPr id="1" name="">
+          <a:extLst>
+            <a:ext uri="{FF2B5EF4-FFF2-40B4-BE49-F238E27FC236}">
+              <a16:creationId xmlns:a16="http://schemas.microsoft.com/office/drawing/2014/main" id="{D4C10401-EB72-56B6-1AC1-5220647614B3}"/>
+            </a:ext>
+          </a:extLst>
+        </p:cNvPr>
+        <p:cNvGrpSpPr/>
+        <p:nvPr/>
+      </p:nvGrpSpPr>
+      <p:grpSpPr>
+        <a:xfrm>
+          <a:off x="0" y="0"/>
+          <a:ext cx="0" cy="0"/>
+          <a:chOff x="0" y="0"/>
+          <a:chExt cx="0" cy="0"/>
+        </a:xfrm>
+      </p:grpSpPr>
+      <p:grpSp>
+        <p:nvGrpSpPr>
+          <p:cNvPr id="25" name="Group 24">
+            <a:extLst>
+              <a:ext uri="{FF2B5EF4-FFF2-40B4-BE49-F238E27FC236}">
+                <a16:creationId xmlns:a16="http://schemas.microsoft.com/office/drawing/2014/main" id="{9368A916-8693-934E-A8E5-DC7ADA9CD39B}"/>
+              </a:ext>
+            </a:extLst>
+          </p:cNvPr>
+          <p:cNvGrpSpPr/>
+          <p:nvPr/>
+        </p:nvGrpSpPr>
+        <p:grpSpPr>
+          <a:xfrm>
+            <a:off x="-128827" y="104924"/>
+            <a:ext cx="3608149" cy="3245694"/>
+            <a:chOff x="-128827" y="104924"/>
+            <a:chExt cx="3608149" cy="3245694"/>
+          </a:xfrm>
+        </p:grpSpPr>
+        <p:sp>
+          <p:nvSpPr>
+            <p:cNvPr id="18" name="Rectangle 17">
+              <a:extLst>
+                <a:ext uri="{FF2B5EF4-FFF2-40B4-BE49-F238E27FC236}">
+                  <a16:creationId xmlns:a16="http://schemas.microsoft.com/office/drawing/2014/main" id="{E1104D5C-7A77-86FA-D92B-44EDD9515128}"/>
+                </a:ext>
+              </a:extLst>
+            </p:cNvPr>
+            <p:cNvSpPr/>
+            <p:nvPr/>
+          </p:nvSpPr>
+          <p:spPr>
+            <a:xfrm>
+              <a:off x="-128826" y="104924"/>
+              <a:ext cx="3608148" cy="3245694"/>
+            </a:xfrm>
+            <a:prstGeom prst="rect">
+              <a:avLst/>
+            </a:prstGeom>
+            <a:solidFill>
+              <a:schemeClr val="bg1"/>
+            </a:solidFill>
+            <a:ln>
+              <a:noFill/>
+            </a:ln>
+          </p:spPr>
+          <p:style>
+            <a:lnRef idx="2">
+              <a:schemeClr val="accent1">
+                <a:shade val="15000"/>
+              </a:schemeClr>
+            </a:lnRef>
+            <a:fillRef idx="1">
+              <a:schemeClr val="accent1"/>
+            </a:fillRef>
+            <a:effectRef idx="0">
+              <a:schemeClr val="accent1"/>
+            </a:effectRef>
+            <a:fontRef idx="minor">
+              <a:schemeClr val="lt1"/>
+            </a:fontRef>
+          </p:style>
+          <p:txBody>
+            <a:bodyPr rtlCol="0" anchor="ctr"/>
+            <a:lstStyle/>
+            <a:p>
+              <a:pPr algn="ctr"/>
+              <a:endParaRPr lang="en-CA"/>
+            </a:p>
+          </p:txBody>
+        </p:sp>
+        <p:pic>
+          <p:nvPicPr>
+            <p:cNvPr id="6" name="Picture 5" descr="A graph of different colored bars&#10;&#10;Description automatically generated with medium confidence">
+              <a:extLst>
+                <a:ext uri="{FF2B5EF4-FFF2-40B4-BE49-F238E27FC236}">
+                  <a16:creationId xmlns:a16="http://schemas.microsoft.com/office/drawing/2014/main" id="{8809CBC2-B370-D05C-CAF3-9C7B268FC04A}"/>
+                </a:ext>
+              </a:extLst>
+            </p:cNvPr>
+            <p:cNvPicPr>
+              <a:picLocks noChangeAspect="1"/>
+            </p:cNvPicPr>
+            <p:nvPr/>
+          </p:nvPicPr>
+          <p:blipFill>
+            <a:blip r:embed="rId2">
+              <a:alphaModFix/>
+            </a:blip>
+            <a:stretch>
+              <a:fillRect/>
+            </a:stretch>
+          </p:blipFill>
+          <p:spPr>
+            <a:xfrm>
+              <a:off x="-128827" y="104924"/>
+              <a:ext cx="3240088" cy="3245694"/>
+            </a:xfrm>
+            <a:prstGeom prst="rect">
+              <a:avLst/>
+            </a:prstGeom>
+          </p:spPr>
+        </p:pic>
+        <p:grpSp>
+          <p:nvGrpSpPr>
+            <p:cNvPr id="15" name="Group 14">
+              <a:extLst>
+                <a:ext uri="{FF2B5EF4-FFF2-40B4-BE49-F238E27FC236}">
+                  <a16:creationId xmlns:a16="http://schemas.microsoft.com/office/drawing/2014/main" id="{458F52C6-61D7-A8CC-45FA-2F83A66884F8}"/>
+                </a:ext>
+              </a:extLst>
+            </p:cNvPr>
+            <p:cNvGrpSpPr>
+              <a:grpSpLocks noChangeAspect="1"/>
+            </p:cNvGrpSpPr>
+            <p:nvPr/>
+          </p:nvGrpSpPr>
+          <p:grpSpPr>
+            <a:xfrm>
+              <a:off x="2429120" y="322053"/>
+              <a:ext cx="739650" cy="501983"/>
+              <a:chOff x="3240088" y="255583"/>
+              <a:chExt cx="1711594" cy="1161618"/>
+            </a:xfrm>
+          </p:grpSpPr>
+          <p:sp>
+            <p:nvSpPr>
+              <p:cNvPr id="8" name="Rectangle 7">
+                <a:extLst>
+                  <a:ext uri="{FF2B5EF4-FFF2-40B4-BE49-F238E27FC236}">
+                    <a16:creationId xmlns:a16="http://schemas.microsoft.com/office/drawing/2014/main" id="{D059EDA7-3125-599D-5626-5CEA1A46300A}"/>
+                  </a:ext>
+                </a:extLst>
+              </p:cNvPr>
+              <p:cNvSpPr/>
+              <p:nvPr/>
+            </p:nvSpPr>
+            <p:spPr>
+              <a:xfrm>
+                <a:off x="3240088" y="255583"/>
+                <a:ext cx="1711594" cy="1161618"/>
+              </a:xfrm>
+              <a:prstGeom prst="rect">
+                <a:avLst/>
+              </a:prstGeom>
+              <a:solidFill>
+                <a:schemeClr val="bg1"/>
+              </a:solidFill>
+              <a:ln>
+                <a:noFill/>
+              </a:ln>
+            </p:spPr>
+            <p:style>
+              <a:lnRef idx="2">
+                <a:schemeClr val="accent1">
+                  <a:shade val="15000"/>
+                </a:schemeClr>
+              </a:lnRef>
+              <a:fillRef idx="1">
+                <a:schemeClr val="accent1"/>
+              </a:fillRef>
+              <a:effectRef idx="0">
+                <a:schemeClr val="accent1"/>
+              </a:effectRef>
+              <a:fontRef idx="minor">
+                <a:schemeClr val="lt1"/>
+              </a:fontRef>
+            </p:style>
+            <p:txBody>
+              <a:bodyPr rtlCol="0" anchor="ctr"/>
+              <a:lstStyle/>
+              <a:p>
+                <a:pPr algn="ctr"/>
+                <a:endParaRPr lang="en-CA"/>
+              </a:p>
+            </p:txBody>
+          </p:sp>
           <p:grpSp>
             <p:nvGrpSpPr>
-              <p:cNvPr id="15" name="Group 14">
+              <p:cNvPr id="9" name="Group 8">
                 <a:extLst>
                   <a:ext uri="{FF2B5EF4-FFF2-40B4-BE49-F238E27FC236}">
-                    <a16:creationId xmlns:a16="http://schemas.microsoft.com/office/drawing/2014/main" id="{8A3C0CDA-857B-1C7D-30D6-2ADDA00FBF0F}"/>
+                    <a16:creationId xmlns:a16="http://schemas.microsoft.com/office/drawing/2014/main" id="{7E88E006-D192-1477-8B24-4BF29F27B3BB}"/>
                   </a:ext>
                 </a:extLst>
               </p:cNvPr>
@@ -3105,18 +3752,105 @@
             </p:nvGrpSpPr>
             <p:grpSpPr>
               <a:xfrm>
-                <a:off x="2371611" y="437072"/>
-                <a:ext cx="739650" cy="501983"/>
-                <a:chOff x="3240088" y="255583"/>
-                <a:chExt cx="1711594" cy="1161618"/>
+                <a:off x="3260676" y="255583"/>
+                <a:ext cx="1691006" cy="1161618"/>
+                <a:chOff x="9482516" y="765949"/>
+                <a:chExt cx="1147704" cy="788402"/>
               </a:xfrm>
             </p:grpSpPr>
+            <p:pic>
+              <p:nvPicPr>
+                <p:cNvPr id="10" name="Picture 9" descr="A graph of different colored bars&#10;&#10;Description automatically generated">
+                  <a:extLst>
+                    <a:ext uri="{FF2B5EF4-FFF2-40B4-BE49-F238E27FC236}">
+                      <a16:creationId xmlns:a16="http://schemas.microsoft.com/office/drawing/2014/main" id="{5DBB93FA-1D2B-334C-7696-27BD525D37D7}"/>
+                    </a:ext>
+                  </a:extLst>
+                </p:cNvPr>
+                <p:cNvPicPr>
+                  <a:picLocks noChangeAspect="1"/>
+                </p:cNvPicPr>
+                <p:nvPr/>
+              </p:nvPicPr>
+              <p:blipFill>
+                <a:blip r:embed="rId3"/>
+                <a:srcRect l="13303" t="8758" r="76614" b="88440"/>
+                <a:stretch/>
+              </p:blipFill>
+              <p:spPr>
+                <a:xfrm>
+                  <a:off x="9485166" y="765949"/>
+                  <a:ext cx="933612" cy="192100"/>
+                </a:xfrm>
+                <a:prstGeom prst="rect">
+                  <a:avLst/>
+                </a:prstGeom>
+              </p:spPr>
+            </p:pic>
+            <p:pic>
+              <p:nvPicPr>
+                <p:cNvPr id="11" name="Picture 10" descr="A graph of different colored bars&#10;&#10;Description automatically generated">
+                  <a:extLst>
+                    <a:ext uri="{FF2B5EF4-FFF2-40B4-BE49-F238E27FC236}">
+                      <a16:creationId xmlns:a16="http://schemas.microsoft.com/office/drawing/2014/main" id="{2CA5C529-DD39-1626-AABA-B8FFA51CDEB8}"/>
+                    </a:ext>
+                  </a:extLst>
+                </p:cNvPr>
+                <p:cNvPicPr>
+                  <a:picLocks noChangeAspect="1"/>
+                </p:cNvPicPr>
+                <p:nvPr/>
+              </p:nvPicPr>
+              <p:blipFill>
+                <a:blip r:embed="rId3"/>
+                <a:srcRect l="40980" t="9132" r="47263" b="88496"/>
+                <a:stretch/>
+              </p:blipFill>
+              <p:spPr>
+                <a:xfrm>
+                  <a:off x="9506962" y="986221"/>
+                  <a:ext cx="1088570" cy="162646"/>
+                </a:xfrm>
+                <a:prstGeom prst="rect">
+                  <a:avLst/>
+                </a:prstGeom>
+              </p:spPr>
+            </p:pic>
+            <p:pic>
+              <p:nvPicPr>
+                <p:cNvPr id="12" name="Picture 11" descr="A graph of different colored bars&#10;&#10;Description automatically generated">
+                  <a:extLst>
+                    <a:ext uri="{FF2B5EF4-FFF2-40B4-BE49-F238E27FC236}">
+                      <a16:creationId xmlns:a16="http://schemas.microsoft.com/office/drawing/2014/main" id="{EB95929A-0A9D-0F79-F115-9A3C01F5ED40}"/>
+                    </a:ext>
+                  </a:extLst>
+                </p:cNvPr>
+                <p:cNvPicPr>
+                  <a:picLocks noChangeAspect="1"/>
+                </p:cNvPicPr>
+                <p:nvPr/>
+              </p:nvPicPr>
+              <p:blipFill>
+                <a:blip r:embed="rId3"/>
+                <a:srcRect l="69279" t="9118" r="18549" b="88229"/>
+                <a:stretch/>
+              </p:blipFill>
+              <p:spPr>
+                <a:xfrm>
+                  <a:off x="9503230" y="1177040"/>
+                  <a:ext cx="1126990" cy="181889"/>
+                </a:xfrm>
+                <a:prstGeom prst="rect">
+                  <a:avLst/>
+                </a:prstGeom>
+              </p:spPr>
+            </p:pic>
             <p:sp>
               <p:nvSpPr>
-                <p:cNvPr id="8" name="Rectangle 7">
+                <p:cNvPr id="13" name="Rectangle 12">
                   <a:extLst>
                     <a:ext uri="{FF2B5EF4-FFF2-40B4-BE49-F238E27FC236}">
-                      <a16:creationId xmlns:a16="http://schemas.microsoft.com/office/drawing/2014/main" id="{291B02BE-F5DF-5B97-DCF6-66B720E3C4D7}"/>
+                      <a16:creationId xmlns:a16="http://schemas.microsoft.com/office/drawing/2014/main" id="{AC503DF4-C1F2-E4AD-360D-6CCDD70D2D9E}"/>
                     </a:ext>
                   </a:extLst>
                 </p:cNvPr>
@@ -3125,8 +3859,8 @@
               </p:nvSpPr>
               <p:spPr>
                 <a:xfrm>
-                  <a:off x="3240088" y="255583"/>
-                  <a:ext cx="1711594" cy="1161618"/>
+                  <a:off x="9482516" y="1336186"/>
+                  <a:ext cx="202660" cy="104503"/>
                 </a:xfrm>
                 <a:prstGeom prst="rect">
                   <a:avLst/>
@@ -3163,243 +3897,43 @@
                 </a:p>
               </p:txBody>
             </p:sp>
-            <p:grpSp>
-              <p:nvGrpSpPr>
-                <p:cNvPr id="9" name="Group 8">
+            <p:pic>
+              <p:nvPicPr>
+                <p:cNvPr id="14" name="Picture 13" descr="A graph of different colored bars&#10;&#10;Description automatically generated">
                   <a:extLst>
                     <a:ext uri="{FF2B5EF4-FFF2-40B4-BE49-F238E27FC236}">
-                      <a16:creationId xmlns:a16="http://schemas.microsoft.com/office/drawing/2014/main" id="{9FAC2967-BC6B-20FD-74FD-4D81DDC2C117}"/>
+                      <a16:creationId xmlns:a16="http://schemas.microsoft.com/office/drawing/2014/main" id="{716762C5-7DEF-4810-B540-A7173FDA6DFE}"/>
                     </a:ext>
                   </a:extLst>
                 </p:cNvPr>
-                <p:cNvGrpSpPr>
-                  <a:grpSpLocks noChangeAspect="1"/>
-                </p:cNvGrpSpPr>
+                <p:cNvPicPr>
+                  <a:picLocks noChangeAspect="1"/>
+                </p:cNvPicPr>
                 <p:nvPr/>
-              </p:nvGrpSpPr>
-              <p:grpSpPr>
+              </p:nvPicPr>
+              <p:blipFill>
+                <a:blip r:embed="rId3"/>
+                <a:srcRect l="69279" t="11611" r="18549" b="85736"/>
+                <a:stretch/>
+              </p:blipFill>
+              <p:spPr>
                 <a:xfrm>
-                  <a:off x="3260676" y="255583"/>
-                  <a:ext cx="1691006" cy="1161618"/>
-                  <a:chOff x="9482516" y="765949"/>
-                  <a:chExt cx="1147704" cy="788402"/>
+                  <a:off x="9503230" y="1372463"/>
+                  <a:ext cx="1126990" cy="181888"/>
                 </a:xfrm>
-              </p:grpSpPr>
-              <p:pic>
-                <p:nvPicPr>
-                  <p:cNvPr id="10" name="Picture 9" descr="A graph of different colored bars&#10;&#10;Description automatically generated">
-                    <a:extLst>
-                      <a:ext uri="{FF2B5EF4-FFF2-40B4-BE49-F238E27FC236}">
-                        <a16:creationId xmlns:a16="http://schemas.microsoft.com/office/drawing/2014/main" id="{1B48769C-57FC-8D2D-908D-B2F669A7BDBB}"/>
-                      </a:ext>
-                    </a:extLst>
-                  </p:cNvPr>
-                  <p:cNvPicPr>
-                    <a:picLocks noChangeAspect="1"/>
-                  </p:cNvPicPr>
-                  <p:nvPr/>
-                </p:nvPicPr>
-                <p:blipFill>
-                  <a:blip r:embed="rId3"/>
-                  <a:srcRect l="13303" t="8758" r="76614" b="88440"/>
-                  <a:stretch/>
-                </p:blipFill>
-                <p:spPr>
-                  <a:xfrm>
-                    <a:off x="9485166" y="765949"/>
-                    <a:ext cx="933612" cy="192100"/>
-                  </a:xfrm>
-                  <a:prstGeom prst="rect">
-                    <a:avLst/>
-                  </a:prstGeom>
-                </p:spPr>
-              </p:pic>
-              <p:pic>
-                <p:nvPicPr>
-                  <p:cNvPr id="11" name="Picture 10" descr="A graph of different colored bars&#10;&#10;Description automatically generated">
-                    <a:extLst>
-                      <a:ext uri="{FF2B5EF4-FFF2-40B4-BE49-F238E27FC236}">
-                        <a16:creationId xmlns:a16="http://schemas.microsoft.com/office/drawing/2014/main" id="{22710543-E87F-7C86-EEB1-E10A6764365B}"/>
-                      </a:ext>
-                    </a:extLst>
-                  </p:cNvPr>
-                  <p:cNvPicPr>
-                    <a:picLocks noChangeAspect="1"/>
-                  </p:cNvPicPr>
-                  <p:nvPr/>
-                </p:nvPicPr>
-                <p:blipFill>
-                  <a:blip r:embed="rId3"/>
-                  <a:srcRect l="40980" t="9132" r="47263" b="88496"/>
-                  <a:stretch/>
-                </p:blipFill>
-                <p:spPr>
-                  <a:xfrm>
-                    <a:off x="9506962" y="986221"/>
-                    <a:ext cx="1088570" cy="162646"/>
-                  </a:xfrm>
-                  <a:prstGeom prst="rect">
-                    <a:avLst/>
-                  </a:prstGeom>
-                </p:spPr>
-              </p:pic>
-              <p:pic>
-                <p:nvPicPr>
-                  <p:cNvPr id="12" name="Picture 11" descr="A graph of different colored bars&#10;&#10;Description automatically generated">
-                    <a:extLst>
-                      <a:ext uri="{FF2B5EF4-FFF2-40B4-BE49-F238E27FC236}">
-                        <a16:creationId xmlns:a16="http://schemas.microsoft.com/office/drawing/2014/main" id="{C7E290C8-BF37-938F-7800-1BE466EC699A}"/>
-                      </a:ext>
-                    </a:extLst>
-                  </p:cNvPr>
-                  <p:cNvPicPr>
-                    <a:picLocks noChangeAspect="1"/>
-                  </p:cNvPicPr>
-                  <p:nvPr/>
-                </p:nvPicPr>
-                <p:blipFill>
-                  <a:blip r:embed="rId3"/>
-                  <a:srcRect l="69279" t="9118" r="18549" b="88229"/>
-                  <a:stretch/>
-                </p:blipFill>
-                <p:spPr>
-                  <a:xfrm>
-                    <a:off x="9503230" y="1177040"/>
-                    <a:ext cx="1126990" cy="181889"/>
-                  </a:xfrm>
-                  <a:prstGeom prst="rect">
-                    <a:avLst/>
-                  </a:prstGeom>
-                </p:spPr>
-              </p:pic>
-              <p:sp>
-                <p:nvSpPr>
-                  <p:cNvPr id="13" name="Rectangle 12">
-                    <a:extLst>
-                      <a:ext uri="{FF2B5EF4-FFF2-40B4-BE49-F238E27FC236}">
-                        <a16:creationId xmlns:a16="http://schemas.microsoft.com/office/drawing/2014/main" id="{A266BE03-F4E6-395F-9EBE-AD5000DD37D9}"/>
-                      </a:ext>
-                    </a:extLst>
-                  </p:cNvPr>
-                  <p:cNvSpPr/>
-                  <p:nvPr/>
-                </p:nvSpPr>
-                <p:spPr>
-                  <a:xfrm>
-                    <a:off x="9482516" y="1336186"/>
-                    <a:ext cx="202660" cy="104503"/>
-                  </a:xfrm>
-                  <a:prstGeom prst="rect">
-                    <a:avLst/>
-                  </a:prstGeom>
-                  <a:solidFill>
-                    <a:schemeClr val="bg1"/>
-                  </a:solidFill>
-                  <a:ln>
-                    <a:noFill/>
-                  </a:ln>
-                </p:spPr>
-                <p:style>
-                  <a:lnRef idx="2">
-                    <a:schemeClr val="accent1">
-                      <a:shade val="15000"/>
-                    </a:schemeClr>
-                  </a:lnRef>
-                  <a:fillRef idx="1">
-                    <a:schemeClr val="accent1"/>
-                  </a:fillRef>
-                  <a:effectRef idx="0">
-                    <a:schemeClr val="accent1"/>
-                  </a:effectRef>
-                  <a:fontRef idx="minor">
-                    <a:schemeClr val="lt1"/>
-                  </a:fontRef>
-                </p:style>
-                <p:txBody>
-                  <a:bodyPr rtlCol="0" anchor="ctr"/>
-                  <a:lstStyle/>
-                  <a:p>
-                    <a:pPr algn="ctr"/>
-                    <a:endParaRPr lang="en-CA"/>
-                  </a:p>
-                </p:txBody>
-              </p:sp>
-              <p:pic>
-                <p:nvPicPr>
-                  <p:cNvPr id="14" name="Picture 13" descr="A graph of different colored bars&#10;&#10;Description automatically generated">
-                    <a:extLst>
-                      <a:ext uri="{FF2B5EF4-FFF2-40B4-BE49-F238E27FC236}">
-                        <a16:creationId xmlns:a16="http://schemas.microsoft.com/office/drawing/2014/main" id="{5A64326F-D0E3-7F75-97B1-2C7FCAE6CA1A}"/>
-                      </a:ext>
-                    </a:extLst>
-                  </p:cNvPr>
-                  <p:cNvPicPr>
-                    <a:picLocks noChangeAspect="1"/>
-                  </p:cNvPicPr>
-                  <p:nvPr/>
-                </p:nvPicPr>
-                <p:blipFill>
-                  <a:blip r:embed="rId3"/>
-                  <a:srcRect l="69279" t="11611" r="18549" b="85736"/>
-                  <a:stretch/>
-                </p:blipFill>
-                <p:spPr>
-                  <a:xfrm>
-                    <a:off x="9503230" y="1372463"/>
-                    <a:ext cx="1126990" cy="181888"/>
-                  </a:xfrm>
-                  <a:prstGeom prst="rect">
-                    <a:avLst/>
-                  </a:prstGeom>
-                </p:spPr>
-              </p:pic>
-            </p:grpSp>
+                <a:prstGeom prst="rect">
+                  <a:avLst/>
+                </a:prstGeom>
+              </p:spPr>
+            </p:pic>
           </p:grpSp>
-          <p:sp>
-            <p:nvSpPr>
-              <p:cNvPr id="17" name="TextBox 16">
-                <a:extLst>
-                  <a:ext uri="{FF2B5EF4-FFF2-40B4-BE49-F238E27FC236}">
-                    <a16:creationId xmlns:a16="http://schemas.microsoft.com/office/drawing/2014/main" id="{E5CE0926-D296-AD78-EF60-7803D78B1D42}"/>
-                  </a:ext>
-                </a:extLst>
-              </p:cNvPr>
-              <p:cNvSpPr txBox="1"/>
-              <p:nvPr/>
-            </p:nvSpPr>
-            <p:spPr>
-              <a:xfrm>
-                <a:off x="3019322" y="2150854"/>
-                <a:ext cx="517585" cy="200055"/>
-              </a:xfrm>
-              <a:prstGeom prst="rect">
-                <a:avLst/>
-              </a:prstGeom>
-              <a:noFill/>
-            </p:spPr>
-            <p:txBody>
-              <a:bodyPr wrap="square" rtlCol="0">
-                <a:spAutoFit/>
-              </a:bodyPr>
-              <a:lstStyle/>
-              <a:p>
-                <a:r>
-                  <a:rPr lang="en-CA" sz="700" dirty="0">
-                    <a:latin typeface="Roboto Condensed Light" pitchFamily="2" charset="0"/>
-                    <a:ea typeface="Roboto Condensed Light" pitchFamily="2" charset="0"/>
-                  </a:rPr>
-                  <a:t>doubling</a:t>
-                </a:r>
-              </a:p>
-            </p:txBody>
-          </p:sp>
         </p:grpSp>
         <p:sp>
           <p:nvSpPr>
-            <p:cNvPr id="20" name="TextBox 19">
+            <p:cNvPr id="21" name="TextBox 20">
               <a:extLst>
                 <a:ext uri="{FF2B5EF4-FFF2-40B4-BE49-F238E27FC236}">
-                  <a16:creationId xmlns:a16="http://schemas.microsoft.com/office/drawing/2014/main" id="{C49764AE-06B5-5B82-58B1-4E417C8CDFCE}"/>
+                  <a16:creationId xmlns:a16="http://schemas.microsoft.com/office/drawing/2014/main" id="{171FFF4C-2DEA-18F8-11AC-3F81D0E4005C}"/>
                 </a:ext>
               </a:extLst>
             </p:cNvPr>
@@ -3408,7 +3942,127 @@
           </p:nvSpPr>
           <p:spPr>
             <a:xfrm>
-              <a:off x="2546986" y="450118"/>
+              <a:off x="2608473" y="457024"/>
+              <a:ext cx="693102" cy="107722"/>
+            </a:xfrm>
+            <a:prstGeom prst="rect">
+              <a:avLst/>
+            </a:prstGeom>
+            <a:solidFill>
+              <a:schemeClr val="bg1"/>
+            </a:solidFill>
+          </p:spPr>
+          <p:txBody>
+            <a:bodyPr wrap="square" lIns="0" tIns="0" bIns="0" rtlCol="0">
+              <a:spAutoFit/>
+            </a:bodyPr>
+            <a:lstStyle/>
+            <a:p>
+              <a:r>
+                <a:rPr lang="en-CA" sz="700" dirty="0">
+                  <a:latin typeface="Roboto Condensed" pitchFamily="2" charset="0"/>
+                  <a:ea typeface="Roboto Condensed" pitchFamily="2" charset="0"/>
+                </a:rPr>
+                <a:t>Bioblitz Effect</a:t>
+              </a:r>
+            </a:p>
+          </p:txBody>
+        </p:sp>
+        <p:sp>
+          <p:nvSpPr>
+            <p:cNvPr id="23" name="TextBox 22">
+              <a:extLst>
+                <a:ext uri="{FF2B5EF4-FFF2-40B4-BE49-F238E27FC236}">
+                  <a16:creationId xmlns:a16="http://schemas.microsoft.com/office/drawing/2014/main" id="{F24D0893-0BBB-1C99-65D3-E2884AEF5DF3}"/>
+                </a:ext>
+              </a:extLst>
+            </p:cNvPr>
+            <p:cNvSpPr txBox="1"/>
+            <p:nvPr/>
+          </p:nvSpPr>
+          <p:spPr>
+            <a:xfrm>
+              <a:off x="2603698" y="705294"/>
+              <a:ext cx="693102" cy="107722"/>
+            </a:xfrm>
+            <a:prstGeom prst="rect">
+              <a:avLst/>
+            </a:prstGeom>
+            <a:solidFill>
+              <a:schemeClr val="bg1"/>
+            </a:solidFill>
+          </p:spPr>
+          <p:txBody>
+            <a:bodyPr wrap="square" lIns="0" tIns="0" bIns="0" rtlCol="0">
+              <a:spAutoFit/>
+            </a:bodyPr>
+            <a:lstStyle/>
+            <a:p>
+              <a:r>
+                <a:rPr lang="en-CA" sz="700" dirty="0">
+                  <a:latin typeface="Roboto Condensed" pitchFamily="2" charset="0"/>
+                  <a:ea typeface="Roboto Condensed" pitchFamily="2" charset="0"/>
+                </a:rPr>
+                <a:t>Expectation</a:t>
+              </a:r>
+            </a:p>
+          </p:txBody>
+        </p:sp>
+        <p:sp>
+          <p:nvSpPr>
+            <p:cNvPr id="22" name="TextBox 21">
+              <a:extLst>
+                <a:ext uri="{FF2B5EF4-FFF2-40B4-BE49-F238E27FC236}">
+                  <a16:creationId xmlns:a16="http://schemas.microsoft.com/office/drawing/2014/main" id="{7468463D-3296-2544-74C5-D133FF3078FD}"/>
+                </a:ext>
+              </a:extLst>
+            </p:cNvPr>
+            <p:cNvSpPr txBox="1"/>
+            <p:nvPr/>
+          </p:nvSpPr>
+          <p:spPr>
+            <a:xfrm>
+              <a:off x="2603698" y="586552"/>
+              <a:ext cx="693102" cy="107722"/>
+            </a:xfrm>
+            <a:prstGeom prst="rect">
+              <a:avLst/>
+            </a:prstGeom>
+            <a:solidFill>
+              <a:schemeClr val="bg1"/>
+            </a:solidFill>
+          </p:spPr>
+          <p:txBody>
+            <a:bodyPr wrap="square" lIns="0" tIns="0" bIns="0" rtlCol="0">
+              <a:spAutoFit/>
+            </a:bodyPr>
+            <a:lstStyle/>
+            <a:p>
+              <a:r>
+                <a:rPr lang="en-CA" sz="700" dirty="0">
+                  <a:latin typeface="Roboto Condensed" pitchFamily="2" charset="0"/>
+                  <a:ea typeface="Roboto Condensed" pitchFamily="2" charset="0"/>
+                </a:rPr>
+                <a:t>Funding Effect</a:t>
+              </a:r>
+            </a:p>
+          </p:txBody>
+        </p:sp>
+        <p:sp>
+          <p:nvSpPr>
+            <p:cNvPr id="20" name="TextBox 19">
+              <a:extLst>
+                <a:ext uri="{FF2B5EF4-FFF2-40B4-BE49-F238E27FC236}">
+                  <a16:creationId xmlns:a16="http://schemas.microsoft.com/office/drawing/2014/main" id="{2FFF6EF6-149A-CD25-CCAF-B4D2DF458985}"/>
+                </a:ext>
+              </a:extLst>
+            </p:cNvPr>
+            <p:cNvSpPr txBox="1"/>
+            <p:nvPr/>
+          </p:nvSpPr>
+          <p:spPr>
+            <a:xfrm>
+              <a:off x="2604495" y="329348"/>
               <a:ext cx="693102" cy="107722"/>
             </a:xfrm>
             <a:prstGeom prst="rect">
@@ -3436,10 +4090,10 @@
         </p:sp>
         <p:sp>
           <p:nvSpPr>
-            <p:cNvPr id="21" name="TextBox 20">
+            <p:cNvPr id="17" name="TextBox 16">
               <a:extLst>
                 <a:ext uri="{FF2B5EF4-FFF2-40B4-BE49-F238E27FC236}">
-                  <a16:creationId xmlns:a16="http://schemas.microsoft.com/office/drawing/2014/main" id="{2D6FCE85-8B3E-AA5E-16D5-8F1791D26FEA}"/>
+                  <a16:creationId xmlns:a16="http://schemas.microsoft.com/office/drawing/2014/main" id="{507E3226-B7CA-4BE1-BBC3-0245B4865846}"/>
                 </a:ext>
               </a:extLst>
             </p:cNvPr>
@@ -3448,108 +4102,26 @@
           </p:nvSpPr>
           <p:spPr>
             <a:xfrm>
-              <a:off x="2550964" y="577794"/>
-              <a:ext cx="693102" cy="107722"/>
+              <a:off x="3001424" y="2329133"/>
+              <a:ext cx="477897" cy="200055"/>
             </a:xfrm>
             <a:prstGeom prst="rect">
               <a:avLst/>
             </a:prstGeom>
-            <a:solidFill>
-              <a:schemeClr val="bg1"/>
-            </a:solidFill>
+            <a:noFill/>
           </p:spPr>
           <p:txBody>
-            <a:bodyPr wrap="square" lIns="0" tIns="0" bIns="0" rtlCol="0">
+            <a:bodyPr wrap="square" rIns="36000" rtlCol="0">
               <a:spAutoFit/>
             </a:bodyPr>
             <a:lstStyle/>
             <a:p>
               <a:r>
                 <a:rPr lang="en-CA" sz="700" dirty="0">
-                  <a:latin typeface="Roboto Condensed" pitchFamily="2" charset="0"/>
-                  <a:ea typeface="Roboto Condensed" pitchFamily="2" charset="0"/>
+                  <a:latin typeface="Roboto Condensed Light" pitchFamily="2" charset="0"/>
+                  <a:ea typeface="Roboto Condensed Light" pitchFamily="2" charset="0"/>
                 </a:rPr>
-                <a:t>Bioblitz Effect</a:t>
-              </a:r>
-            </a:p>
-          </p:txBody>
-        </p:sp>
-        <p:sp>
-          <p:nvSpPr>
-            <p:cNvPr id="22" name="TextBox 21">
-              <a:extLst>
-                <a:ext uri="{FF2B5EF4-FFF2-40B4-BE49-F238E27FC236}">
-                  <a16:creationId xmlns:a16="http://schemas.microsoft.com/office/drawing/2014/main" id="{DD39B340-D881-D7D1-7FDB-D15069D4E1F9}"/>
-                </a:ext>
-              </a:extLst>
-            </p:cNvPr>
-            <p:cNvSpPr txBox="1"/>
-            <p:nvPr/>
-          </p:nvSpPr>
-          <p:spPr>
-            <a:xfrm>
-              <a:off x="2546189" y="707322"/>
-              <a:ext cx="693102" cy="107722"/>
-            </a:xfrm>
-            <a:prstGeom prst="rect">
-              <a:avLst/>
-            </a:prstGeom>
-            <a:solidFill>
-              <a:schemeClr val="bg1"/>
-            </a:solidFill>
-          </p:spPr>
-          <p:txBody>
-            <a:bodyPr wrap="square" lIns="0" tIns="0" bIns="0" rtlCol="0">
-              <a:spAutoFit/>
-            </a:bodyPr>
-            <a:lstStyle/>
-            <a:p>
-              <a:r>
-                <a:rPr lang="en-CA" sz="700" dirty="0">
-                  <a:latin typeface="Roboto Condensed" pitchFamily="2" charset="0"/>
-                  <a:ea typeface="Roboto Condensed" pitchFamily="2" charset="0"/>
-                </a:rPr>
-                <a:t>Funding Effect</a:t>
-              </a:r>
-            </a:p>
-          </p:txBody>
-        </p:sp>
-        <p:sp>
-          <p:nvSpPr>
-            <p:cNvPr id="23" name="TextBox 22">
-              <a:extLst>
-                <a:ext uri="{FF2B5EF4-FFF2-40B4-BE49-F238E27FC236}">
-                  <a16:creationId xmlns:a16="http://schemas.microsoft.com/office/drawing/2014/main" id="{14AAD9EC-2009-535C-0834-489D500A09FB}"/>
-                </a:ext>
-              </a:extLst>
-            </p:cNvPr>
-            <p:cNvSpPr txBox="1"/>
-            <p:nvPr/>
-          </p:nvSpPr>
-          <p:spPr>
-            <a:xfrm>
-              <a:off x="2546189" y="826064"/>
-              <a:ext cx="693102" cy="107722"/>
-            </a:xfrm>
-            <a:prstGeom prst="rect">
-              <a:avLst/>
-            </a:prstGeom>
-            <a:solidFill>
-              <a:schemeClr val="bg1"/>
-            </a:solidFill>
-          </p:spPr>
-          <p:txBody>
-            <a:bodyPr wrap="square" lIns="0" tIns="0" bIns="0" rtlCol="0">
-              <a:spAutoFit/>
-            </a:bodyPr>
-            <a:lstStyle/>
-            <a:p>
-              <a:r>
-                <a:rPr lang="en-CA" sz="700" dirty="0">
-                  <a:latin typeface="Roboto Condensed" pitchFamily="2" charset="0"/>
-                  <a:ea typeface="Roboto Condensed" pitchFamily="2" charset="0"/>
-                </a:rPr>
-                <a:t>Expectation</a:t>
+                <a:t>doubling</a:t>
               </a:r>
             </a:p>
           </p:txBody>
@@ -3558,7 +4130,7 @@
     </p:spTree>
     <p:extLst>
       <p:ext uri="{BB962C8B-B14F-4D97-AF65-F5344CB8AC3E}">
-        <p14:creationId xmlns:p14="http://schemas.microsoft.com/office/powerpoint/2010/main" val="3188471139"/>
+        <p14:creationId xmlns:p14="http://schemas.microsoft.com/office/powerpoint/2010/main" val="4279131194"/>
       </p:ext>
     </p:extLst>
   </p:cSld>

</xml_diff>